<commit_message>
Fix Arabic text rendering as Chinese / empty squares
pptxgenjs tags every text run with East Asian and complex-script fonts
using Chinese code pages (GB2312, Big5). On devices without the brand
fonts, PowerPoint fell back to a Chinese font and mobile viewers drew
the Arabic as empty boxes. Post-process the slides to use the original
deck's Arabic-only font setup (latin + cs, Arabic code page, ar-SA),
and drop the shadow on the round disc, which some mobile viewers render
as a square.

Co-Authored-By: Claude Opus 5.5 <noreply@anthropic.com>
Claude-Session: https://claude.ai/code/session_015zeHUZ3yxJZ15ckviVZbAL
</commit_message>
<xml_diff>
--- a/company-profile/Samaa_Audiovisual_Productions_-_Company_Profile.pptx
+++ b/company-profile/Samaa_Audiovisual_Productions_-_Company_Profile.pptx
@@ -1606,13 +1606,12 @@
               <a:buNone/>
             </a:pPr>
             <a:r>
-              <a:rPr lang="ar-SA" altLang="en-US" sz="4800" dirty="0">
+              <a:rPr lang="ar-SA" sz="4800" dirty="0">
                 <a:solidFill>
                   <a:srgbClr val="C2BFAF"/>
                 </a:solidFill>
-                <a:latin typeface="FF Taweel" pitchFamily="34" charset="0"/>
-                <a:ea typeface="FF Taweel" pitchFamily="34" charset="-122"/>
-                <a:cs typeface="FF Taweel" pitchFamily="34" charset="-120"/>
+                <a:latin typeface="FF Taweel" pitchFamily="2" charset="-78"/>
+                <a:cs typeface="FF Taweel" pitchFamily="2" charset="-78"/>
               </a:rPr>
               <a:t>من نحن</a:t>
             </a:r>
@@ -1645,13 +1644,12 @@
               <a:buNone/>
             </a:pPr>
             <a:r>
-              <a:rPr lang="ar-SA" altLang="en-US" sz="1500" dirty="0">
+              <a:rPr lang="ar-SA" sz="1500" dirty="0">
                 <a:solidFill>
                   <a:srgbClr val="2AAFC4"/>
                 </a:solidFill>
-                <a:latin typeface="Almarai Bold" pitchFamily="34" charset="0"/>
-                <a:ea typeface="Almarai Bold" pitchFamily="34" charset="-122"/>
-                <a:cs typeface="Almarai Bold" pitchFamily="34" charset="-120"/>
+                <a:latin typeface="Almarai Bold" pitchFamily="2" charset="-78"/>
+                <a:cs typeface="Almarai Bold" pitchFamily="2" charset="-78"/>
               </a:rPr>
               <a:t>سمع للإنتاج الإعلامي المرئي والمسموع</a:t>
             </a:r>
@@ -1690,13 +1688,12 @@
               <a:buNone/>
             </a:pPr>
             <a:r>
-              <a:rPr lang="ar-SA" altLang="en-US" sz="1600" dirty="0">
+              <a:rPr lang="ar-SA" sz="1600" dirty="0">
                 <a:solidFill>
                   <a:srgbClr val="F1EFE8"/>
                 </a:solidFill>
-                <a:latin typeface="Almarai Light" pitchFamily="34" charset="0"/>
-                <a:ea typeface="Almarai Light" pitchFamily="34" charset="-122"/>
-                <a:cs typeface="Almarai Light" pitchFamily="34" charset="-120"/>
+                <a:latin typeface="Almarai Light" pitchFamily="2" charset="-78"/>
+                <a:cs typeface="Almarai Light" pitchFamily="2" charset="-78"/>
               </a:rPr>
               <a:t>شركة سمع للإنتاج الإعلامي شركة متخصصة في إنتاج المحتوى الغنائي بأشكاله المتعددة، عن طريق نخبة من المتخصصين ذوي الخبرة الواسعة في المجال، وباستخدام أحدث تقنيات الإنتاج المرئي والمسموع.</a:t>
             </a:r>
@@ -1710,13 +1707,12 @@
               <a:buNone/>
             </a:pPr>
             <a:r>
-              <a:rPr lang="ar-SA" altLang="en-US" sz="1600" dirty="0">
+              <a:rPr lang="ar-SA" sz="1600" dirty="0">
                 <a:solidFill>
                   <a:srgbClr val="F1EFE8"/>
                 </a:solidFill>
-                <a:latin typeface="Almarai Light" pitchFamily="34" charset="0"/>
-                <a:ea typeface="Almarai Light" pitchFamily="34" charset="-122"/>
-                <a:cs typeface="Almarai Light" pitchFamily="34" charset="-120"/>
+                <a:latin typeface="Almarai Light" pitchFamily="2" charset="-78"/>
+                <a:cs typeface="Almarai Light" pitchFamily="2" charset="-78"/>
               </a:rPr>
               <a:t>كما نقدم خدمات الإنتاج الصوتي المحترف بخبرة تتجاوز 25 عاماً؛ من البودكاست والتعليق الصوتي، إلى التصميم الصوتي ورسائل الرد الآلي للشركات.</a:t>
             </a:r>
@@ -1783,17 +1779,16 @@
               <a:buNone/>
             </a:pPr>
             <a:r>
-              <a:rPr lang="en-US" sz="3600" dirty="0">
+              <a:rPr lang="ar-SA" sz="3600" dirty="0">
                 <a:solidFill>
                   <a:srgbClr val="2AAFC4"/>
                 </a:solidFill>
-                <a:latin typeface="Almarai ExtraBold" pitchFamily="34" charset="0"/>
-                <a:ea typeface="Almarai ExtraBold" pitchFamily="34" charset="-122"/>
-                <a:cs typeface="Almarai ExtraBold" pitchFamily="34" charset="-120"/>
+                <a:latin typeface="Almarai ExtraBold" pitchFamily="2" charset="-78"/>
+                <a:cs typeface="Almarai ExtraBold" pitchFamily="2" charset="-78"/>
               </a:rPr>
               <a:t>13</a:t>
             </a:r>
-            <a:endParaRPr lang="en-US" sz="3600" dirty="0"/>
+            <a:endParaRPr lang="ar-SA" sz="3600" dirty="0"/>
           </a:p>
         </p:txBody>
       </p:sp>
@@ -1822,13 +1817,12 @@
               <a:buNone/>
             </a:pPr>
             <a:r>
-              <a:rPr lang="ar-SA" altLang="en-US" sz="1300" dirty="0">
+              <a:rPr lang="ar-SA" sz="1300" dirty="0">
                 <a:solidFill>
                   <a:srgbClr val="F1EFE8"/>
                 </a:solidFill>
-                <a:latin typeface="Almarai Bold" pitchFamily="34" charset="0"/>
-                <a:ea typeface="Almarai Bold" pitchFamily="34" charset="-122"/>
-                <a:cs typeface="Almarai Bold" pitchFamily="34" charset="-120"/>
+                <a:latin typeface="Almarai Bold" pitchFamily="2" charset="-78"/>
+                <a:cs typeface="Almarai Bold" pitchFamily="2" charset="-78"/>
               </a:rPr>
               <a:t>خدمة إبداعية متخصصة</a:t>
             </a:r>
@@ -1895,17 +1889,16 @@
               <a:buNone/>
             </a:pPr>
             <a:r>
-              <a:rPr lang="en-US" sz="3600" dirty="0">
+              <a:rPr lang="ar-SA" sz="3600" dirty="0">
                 <a:solidFill>
                   <a:srgbClr val="2AAFC4"/>
                 </a:solidFill>
-                <a:latin typeface="Almarai ExtraBold" pitchFamily="34" charset="0"/>
-                <a:ea typeface="Almarai ExtraBold" pitchFamily="34" charset="-122"/>
-                <a:cs typeface="Almarai ExtraBold" pitchFamily="34" charset="-120"/>
+                <a:latin typeface="Almarai ExtraBold" pitchFamily="2" charset="-78"/>
+                <a:cs typeface="Almarai ExtraBold" pitchFamily="2" charset="-78"/>
               </a:rPr>
               <a:t>2</a:t>
             </a:r>
-            <a:endParaRPr lang="en-US" sz="3600" dirty="0"/>
+            <a:endParaRPr lang="ar-SA" sz="3600" dirty="0"/>
           </a:p>
         </p:txBody>
       </p:sp>
@@ -1934,13 +1927,12 @@
               <a:buNone/>
             </a:pPr>
             <a:r>
-              <a:rPr lang="ar-SA" altLang="en-US" sz="1300" dirty="0">
+              <a:rPr lang="ar-SA" sz="1300" dirty="0">
                 <a:solidFill>
                   <a:srgbClr val="F1EFE8"/>
                 </a:solidFill>
-                <a:latin typeface="Almarai Bold" pitchFamily="34" charset="0"/>
-                <a:ea typeface="Almarai Bold" pitchFamily="34" charset="-122"/>
-                <a:cs typeface="Almarai Bold" pitchFamily="34" charset="-120"/>
+                <a:latin typeface="Almarai Bold" pitchFamily="2" charset="-78"/>
+                <a:cs typeface="Almarai Bold" pitchFamily="2" charset="-78"/>
               </a:rPr>
               <a:t>لغتان: العربية والإنجليزية</a:t>
             </a:r>
@@ -1988,13 +1980,6 @@
             <a:srgbClr val="662E8F"/>
           </a:solidFill>
           <a:ln/>
-          <a:effectLst>
-            <a:outerShdw sx="100000" sy="100000" kx="0" ky="0" algn="bl" rotWithShape="0" blurRad="228600" dist="50800" dir="5400000">
-              <a:srgbClr val="000000">
-                <a:alpha val="40000"/>
-              </a:srgbClr>
-            </a:outerShdw>
-          </a:effectLst>
         </p:spPr>
       </p:sp>
       <p:sp>
@@ -2022,17 +2007,16 @@
               <a:buNone/>
             </a:pPr>
             <a:r>
-              <a:rPr lang="en-US" sz="8000" dirty="0">
+              <a:rPr lang="ar-SA" sz="8000" dirty="0">
                 <a:solidFill>
                   <a:srgbClr val="FFFFFF"/>
                 </a:solidFill>
-                <a:latin typeface="Almarai ExtraBold" pitchFamily="34" charset="0"/>
-                <a:ea typeface="Almarai ExtraBold" pitchFamily="34" charset="-122"/>
-                <a:cs typeface="Almarai ExtraBold" pitchFamily="34" charset="-120"/>
+                <a:latin typeface="Almarai ExtraBold" pitchFamily="2" charset="-78"/>
+                <a:cs typeface="Almarai ExtraBold" pitchFamily="2" charset="-78"/>
               </a:rPr>
               <a:t>+25</a:t>
             </a:r>
-            <a:endParaRPr lang="en-US" sz="8000" dirty="0"/>
+            <a:endParaRPr lang="ar-SA" sz="8000" dirty="0"/>
           </a:p>
         </p:txBody>
       </p:sp>
@@ -2061,13 +2045,12 @@
               <a:buNone/>
             </a:pPr>
             <a:r>
-              <a:rPr lang="ar-SA" altLang="en-US" sz="2000" dirty="0">
+              <a:rPr lang="ar-SA" sz="2000" dirty="0">
                 <a:solidFill>
                   <a:srgbClr val="C2BFAF"/>
                 </a:solidFill>
-                <a:latin typeface="Almarai Bold" pitchFamily="34" charset="0"/>
-                <a:ea typeface="Almarai Bold" pitchFamily="34" charset="-122"/>
-                <a:cs typeface="Almarai Bold" pitchFamily="34" charset="-120"/>
+                <a:latin typeface="Almarai Bold" pitchFamily="2" charset="-78"/>
+                <a:cs typeface="Almarai Bold" pitchFamily="2" charset="-78"/>
               </a:rPr>
               <a:t>عاماً من الخبرة</a:t>
             </a:r>
@@ -2224,13 +2207,12 @@
               <a:buNone/>
             </a:pPr>
             <a:r>
-              <a:rPr lang="ar-SA" altLang="en-US" sz="4800" dirty="0">
+              <a:rPr lang="ar-SA" sz="4800" dirty="0">
                 <a:solidFill>
                   <a:srgbClr val="C2BFAF"/>
                 </a:solidFill>
-                <a:latin typeface="FF Taweel" pitchFamily="34" charset="0"/>
-                <a:ea typeface="FF Taweel" pitchFamily="34" charset="-122"/>
-                <a:cs typeface="FF Taweel" pitchFamily="34" charset="-120"/>
+                <a:latin typeface="FF Taweel" pitchFamily="2" charset="-78"/>
+                <a:cs typeface="FF Taweel" pitchFamily="2" charset="-78"/>
               </a:rPr>
               <a:t>شركاء النجاح</a:t>
             </a:r>
@@ -2263,13 +2245,12 @@
               <a:buNone/>
             </a:pPr>
             <a:r>
-              <a:rPr lang="ar-SA" altLang="en-US" sz="1500" dirty="0">
+              <a:rPr lang="ar-SA" sz="1500" dirty="0">
                 <a:solidFill>
                   <a:srgbClr val="2AAFC4"/>
                 </a:solidFill>
-                <a:latin typeface="Almarai Bold" pitchFamily="34" charset="0"/>
-                <a:ea typeface="Almarai Bold" pitchFamily="34" charset="-122"/>
-                <a:cs typeface="Almarai Bold" pitchFamily="34" charset="-120"/>
+                <a:latin typeface="Almarai Bold" pitchFamily="2" charset="-78"/>
+                <a:cs typeface="Almarai Bold" pitchFamily="2" charset="-78"/>
               </a:rPr>
               <a:t>نفخر بخدمة نخبة من أبرز العلامات التجارية</a:t>
             </a:r>
@@ -3356,13 +3337,12 @@
               <a:buNone/>
             </a:pPr>
             <a:r>
-              <a:rPr lang="ar-SA" altLang="en-US" sz="7200" dirty="0">
+              <a:rPr lang="ar-SA" sz="7200" dirty="0">
                 <a:solidFill>
                   <a:srgbClr val="C2BFAF"/>
                 </a:solidFill>
-                <a:latin typeface="FF Taweel" pitchFamily="34" charset="0"/>
-                <a:ea typeface="FF Taweel" pitchFamily="34" charset="-122"/>
-                <a:cs typeface="FF Taweel" pitchFamily="34" charset="-120"/>
+                <a:latin typeface="FF Taweel" pitchFamily="2" charset="-78"/>
+                <a:cs typeface="FF Taweel" pitchFamily="2" charset="-78"/>
               </a:rPr>
               <a:t>خدماتنا</a:t>
             </a:r>
@@ -3395,13 +3375,12 @@
               <a:buNone/>
             </a:pPr>
             <a:r>
-              <a:rPr lang="ar-SA" altLang="en-US" sz="1800" dirty="0">
+              <a:rPr lang="ar-SA" sz="1800" dirty="0">
                 <a:solidFill>
                   <a:srgbClr val="2AAFC4"/>
                 </a:solidFill>
-                <a:latin typeface="Almarai Bold" pitchFamily="34" charset="0"/>
-                <a:ea typeface="Almarai Bold" pitchFamily="34" charset="-122"/>
-                <a:cs typeface="Almarai Bold" pitchFamily="34" charset="-120"/>
+                <a:latin typeface="Almarai Bold" pitchFamily="2" charset="-78"/>
+                <a:cs typeface="Almarai Bold" pitchFamily="2" charset="-78"/>
               </a:rPr>
               <a:t>حلول إبداعية متكاملة في الإنتاج الموسيقي والصوتي</a:t>
             </a:r>
@@ -3517,17 +3496,16 @@
               <a:buNone/>
             </a:pPr>
             <a:r>
-              <a:rPr lang="en-US" sz="4000" dirty="0">
+              <a:rPr lang="ar-SA" sz="4000" dirty="0">
                 <a:solidFill>
                   <a:srgbClr val="4F6370"/>
                 </a:solidFill>
-                <a:latin typeface="Almarai ExtraBold" pitchFamily="34" charset="0"/>
-                <a:ea typeface="Almarai ExtraBold" pitchFamily="34" charset="-122"/>
-                <a:cs typeface="Almarai ExtraBold" pitchFamily="34" charset="-120"/>
+                <a:latin typeface="Almarai ExtraBold" pitchFamily="2" charset="-78"/>
+                <a:cs typeface="Almarai ExtraBold" pitchFamily="2" charset="-78"/>
               </a:rPr>
               <a:t>01</a:t>
             </a:r>
-            <a:endParaRPr lang="en-US" sz="4000" dirty="0"/>
+            <a:endParaRPr lang="ar-SA" sz="4000" dirty="0"/>
           </a:p>
         </p:txBody>
       </p:sp>
@@ -3556,13 +3534,12 @@
               <a:buNone/>
             </a:pPr>
             <a:r>
-              <a:rPr lang="ar-SA" altLang="en-US" sz="2000" dirty="0">
+              <a:rPr lang="ar-SA" sz="2000" dirty="0">
                 <a:solidFill>
                   <a:srgbClr val="F1EFE8"/>
                 </a:solidFill>
-                <a:latin typeface="Almarai Bold" pitchFamily="34" charset="0"/>
-                <a:ea typeface="Almarai Bold" pitchFamily="34" charset="-122"/>
-                <a:cs typeface="Almarai Bold" pitchFamily="34" charset="-120"/>
+                <a:latin typeface="Almarai Bold" pitchFamily="2" charset="-78"/>
+                <a:cs typeface="Almarai Bold" pitchFamily="2" charset="-78"/>
               </a:rPr>
               <a:t>الإنتاج الموسيقي والغنائي</a:t>
             </a:r>
@@ -3598,13 +3575,12 @@
               <a:buNone/>
             </a:pPr>
             <a:r>
-              <a:rPr lang="ar-SA" altLang="en-US" sz="1200" dirty="0">
+              <a:rPr lang="ar-SA" sz="1200" dirty="0">
                 <a:solidFill>
                   <a:srgbClr val="B9C1C7"/>
                 </a:solidFill>
-                <a:latin typeface="Almarai Light" pitchFamily="34" charset="0"/>
-                <a:ea typeface="Almarai Light" pitchFamily="34" charset="-122"/>
-                <a:cs typeface="Almarai Light" pitchFamily="34" charset="-120"/>
+                <a:latin typeface="Almarai Light" pitchFamily="2" charset="-78"/>
+                <a:cs typeface="Almarai Light" pitchFamily="2" charset="-78"/>
               </a:rPr>
               <a:t>كتابة الكلمات • تأليف الألحان • التوزيع الموسيقي • التسجيل • الأغاني الدعائية • الألبومات</a:t>
             </a:r>
@@ -3720,17 +3696,16 @@
               <a:buNone/>
             </a:pPr>
             <a:r>
-              <a:rPr lang="en-US" sz="4000" dirty="0">
+              <a:rPr lang="ar-SA" sz="4000" dirty="0">
                 <a:solidFill>
                   <a:srgbClr val="4F6370"/>
                 </a:solidFill>
-                <a:latin typeface="Almarai ExtraBold" pitchFamily="34" charset="0"/>
-                <a:ea typeface="Almarai ExtraBold" pitchFamily="34" charset="-122"/>
-                <a:cs typeface="Almarai ExtraBold" pitchFamily="34" charset="-120"/>
+                <a:latin typeface="Almarai ExtraBold" pitchFamily="2" charset="-78"/>
+                <a:cs typeface="Almarai ExtraBold" pitchFamily="2" charset="-78"/>
               </a:rPr>
               <a:t>02</a:t>
             </a:r>
-            <a:endParaRPr lang="en-US" sz="4000" dirty="0"/>
+            <a:endParaRPr lang="ar-SA" sz="4000" dirty="0"/>
           </a:p>
         </p:txBody>
       </p:sp>
@@ -3759,13 +3734,12 @@
               <a:buNone/>
             </a:pPr>
             <a:r>
-              <a:rPr lang="ar-SA" altLang="en-US" sz="2000" dirty="0">
+              <a:rPr lang="ar-SA" sz="2000" dirty="0">
                 <a:solidFill>
                   <a:srgbClr val="F1EFE8"/>
                 </a:solidFill>
-                <a:latin typeface="Almarai Bold" pitchFamily="34" charset="0"/>
-                <a:ea typeface="Almarai Bold" pitchFamily="34" charset="-122"/>
-                <a:cs typeface="Almarai Bold" pitchFamily="34" charset="-120"/>
+                <a:latin typeface="Almarai Bold" pitchFamily="2" charset="-78"/>
+                <a:cs typeface="Almarai Bold" pitchFamily="2" charset="-78"/>
               </a:rPr>
               <a:t>الإنتاج الصوتي</a:t>
             </a:r>
@@ -3801,13 +3775,12 @@
               <a:buNone/>
             </a:pPr>
             <a:r>
-              <a:rPr lang="ar-SA" altLang="en-US" sz="1200" dirty="0">
+              <a:rPr lang="ar-SA" sz="1200" dirty="0">
                 <a:solidFill>
                   <a:srgbClr val="B9C1C7"/>
                 </a:solidFill>
-                <a:latin typeface="Almarai Light" pitchFamily="34" charset="0"/>
-                <a:ea typeface="Almarai Light" pitchFamily="34" charset="-122"/>
-                <a:cs typeface="Almarai Light" pitchFamily="34" charset="-120"/>
+                <a:latin typeface="Almarai Light" pitchFamily="2" charset="-78"/>
+                <a:cs typeface="Almarai Light" pitchFamily="2" charset="-78"/>
               </a:rPr>
               <a:t>البودكاست • الرد الآلي • المعلقون الصوتيون • تحرير الصوت • التصميم الصوتي • التعليق الصوتي</a:t>
             </a:r>
@@ -3958,13 +3931,12 @@
               <a:buNone/>
             </a:pPr>
             <a:r>
-              <a:rPr lang="ar-SA" altLang="en-US" sz="6000" dirty="0">
+              <a:rPr lang="ar-SA" sz="6000" dirty="0">
                 <a:solidFill>
                   <a:srgbClr val="C2BFAF"/>
                 </a:solidFill>
-                <a:latin typeface="FF Taweel" pitchFamily="34" charset="0"/>
-                <a:ea typeface="FF Taweel" pitchFamily="34" charset="-122"/>
-                <a:cs typeface="FF Taweel" pitchFamily="34" charset="-120"/>
+                <a:latin typeface="FF Taweel" pitchFamily="2" charset="-78"/>
+                <a:cs typeface="FF Taweel" pitchFamily="2" charset="-78"/>
               </a:rPr>
               <a:t>خدماتنا</a:t>
             </a:r>
@@ -3997,13 +3969,12 @@
               <a:buNone/>
             </a:pPr>
             <a:r>
-              <a:rPr lang="ar-SA" altLang="en-US" sz="1700" dirty="0">
+              <a:rPr lang="ar-SA" sz="1700" dirty="0">
                 <a:solidFill>
                   <a:srgbClr val="FFFFFF"/>
                 </a:solidFill>
-                <a:latin typeface="Almarai Bold" pitchFamily="34" charset="0"/>
-                <a:ea typeface="Almarai Bold" pitchFamily="34" charset="-122"/>
-                <a:cs typeface="Almarai Bold" pitchFamily="34" charset="-120"/>
+                <a:latin typeface="Almarai Bold" pitchFamily="2" charset="-78"/>
+                <a:cs typeface="Almarai Bold" pitchFamily="2" charset="-78"/>
               </a:rPr>
               <a:t>الإنتاج الموسيقي والغنائي</a:t>
             </a:r>
@@ -4085,13 +4056,12 @@
               <a:buNone/>
             </a:pPr>
             <a:r>
-              <a:rPr lang="ar-SA" altLang="en-US" sz="1700" dirty="0">
+              <a:rPr lang="ar-SA" sz="1700" dirty="0">
                 <a:solidFill>
                   <a:srgbClr val="F1EFE8"/>
                 </a:solidFill>
-                <a:latin typeface="Almarai Bold" pitchFamily="34" charset="0"/>
-                <a:ea typeface="Almarai Bold" pitchFamily="34" charset="-122"/>
-                <a:cs typeface="Almarai Bold" pitchFamily="34" charset="-120"/>
+                <a:latin typeface="Almarai Bold" pitchFamily="2" charset="-78"/>
+                <a:cs typeface="Almarai Bold" pitchFamily="2" charset="-78"/>
               </a:rPr>
               <a:t>كتابة الكلمات</a:t>
             </a:r>
@@ -4127,13 +4097,12 @@
               <a:buNone/>
             </a:pPr>
             <a:r>
-              <a:rPr lang="ar-SA" altLang="en-US" sz="1200" dirty="0">
+              <a:rPr lang="ar-SA" sz="1200" dirty="0">
                 <a:solidFill>
                   <a:srgbClr val="B9C1C7"/>
                 </a:solidFill>
-                <a:latin typeface="Almarai Light" pitchFamily="34" charset="0"/>
-                <a:ea typeface="Almarai Light" pitchFamily="34" charset="-122"/>
-                <a:cs typeface="Almarai Light" pitchFamily="34" charset="-120"/>
+                <a:latin typeface="Almarai Light" pitchFamily="2" charset="-78"/>
+                <a:cs typeface="Almarai Light" pitchFamily="2" charset="-78"/>
               </a:rPr>
               <a:t>شبكة واسعة من الشعراء والكتّاب ذوي الخبرة في كتابة الكلمات الغنائية والشعر العربي، بإبداع وسرعة في الإنجاز.</a:t>
             </a:r>
@@ -4215,13 +4184,12 @@
               <a:buNone/>
             </a:pPr>
             <a:r>
-              <a:rPr lang="ar-SA" altLang="en-US" sz="1700" dirty="0">
+              <a:rPr lang="ar-SA" sz="1700" dirty="0">
                 <a:solidFill>
                   <a:srgbClr val="F1EFE8"/>
                 </a:solidFill>
-                <a:latin typeface="Almarai Bold" pitchFamily="34" charset="0"/>
-                <a:ea typeface="Almarai Bold" pitchFamily="34" charset="-122"/>
-                <a:cs typeface="Almarai Bold" pitchFamily="34" charset="-120"/>
+                <a:latin typeface="Almarai Bold" pitchFamily="2" charset="-78"/>
+                <a:cs typeface="Almarai Bold" pitchFamily="2" charset="-78"/>
               </a:rPr>
               <a:t>تأليف الألحان</a:t>
             </a:r>
@@ -4257,13 +4225,12 @@
               <a:buNone/>
             </a:pPr>
             <a:r>
-              <a:rPr lang="ar-SA" altLang="en-US" sz="1200" dirty="0">
+              <a:rPr lang="ar-SA" sz="1200" dirty="0">
                 <a:solidFill>
                   <a:srgbClr val="B9C1C7"/>
                 </a:solidFill>
-                <a:latin typeface="Almarai Light" pitchFamily="34" charset="0"/>
-                <a:ea typeface="Almarai Light" pitchFamily="34" charset="-122"/>
-                <a:cs typeface="Almarai Light" pitchFamily="34" charset="-120"/>
+                <a:latin typeface="Almarai Light" pitchFamily="2" charset="-78"/>
+                <a:cs typeface="Almarai Light" pitchFamily="2" charset="-78"/>
               </a:rPr>
               <a:t>من أكثر خدماتنا تميزاً؛ ألحان شرقية وغربية على أيدي ملحنين محترفين عاشقين للفن بكل أنواعه وتفاصيله.</a:t>
             </a:r>
@@ -4345,13 +4312,12 @@
               <a:buNone/>
             </a:pPr>
             <a:r>
-              <a:rPr lang="ar-SA" altLang="en-US" sz="1700" dirty="0">
+              <a:rPr lang="ar-SA" sz="1700" dirty="0">
                 <a:solidFill>
                   <a:srgbClr val="F1EFE8"/>
                 </a:solidFill>
-                <a:latin typeface="Almarai Bold" pitchFamily="34" charset="0"/>
-                <a:ea typeface="Almarai Bold" pitchFamily="34" charset="-122"/>
-                <a:cs typeface="Almarai Bold" pitchFamily="34" charset="-120"/>
+                <a:latin typeface="Almarai Bold" pitchFamily="2" charset="-78"/>
+                <a:cs typeface="Almarai Bold" pitchFamily="2" charset="-78"/>
               </a:rPr>
               <a:t>التوزيع الموسيقي</a:t>
             </a:r>
@@ -4387,13 +4353,12 @@
               <a:buNone/>
             </a:pPr>
             <a:r>
-              <a:rPr lang="ar-SA" altLang="en-US" sz="1200" dirty="0">
+              <a:rPr lang="ar-SA" sz="1200" dirty="0">
                 <a:solidFill>
                   <a:srgbClr val="B9C1C7"/>
                 </a:solidFill>
-                <a:latin typeface="Almarai Light" pitchFamily="34" charset="0"/>
-                <a:ea typeface="Almarai Light" pitchFamily="34" charset="-122"/>
-                <a:cs typeface="Almarai Light" pitchFamily="34" charset="-120"/>
+                <a:latin typeface="Almarai Light" pitchFamily="2" charset="-78"/>
+                <a:cs typeface="Almarai Light" pitchFamily="2" charset="-78"/>
               </a:rPr>
               <a:t>الورقة الرابحة لعملائنا دوماً؛ توزيع موسيقي دقيق وعلى مستوى فني احترافي عالٍ في استديوهات سمع.</a:t>
             </a:r>
@@ -4475,13 +4440,12 @@
               <a:buNone/>
             </a:pPr>
             <a:r>
-              <a:rPr lang="ar-SA" altLang="en-US" sz="1700" dirty="0">
+              <a:rPr lang="ar-SA" sz="1700" dirty="0">
                 <a:solidFill>
                   <a:srgbClr val="F1EFE8"/>
                 </a:solidFill>
-                <a:latin typeface="Almarai Bold" pitchFamily="34" charset="0"/>
-                <a:ea typeface="Almarai Bold" pitchFamily="34" charset="-122"/>
-                <a:cs typeface="Almarai Bold" pitchFamily="34" charset="-120"/>
+                <a:latin typeface="Almarai Bold" pitchFamily="2" charset="-78"/>
+                <a:cs typeface="Almarai Bold" pitchFamily="2" charset="-78"/>
               </a:rPr>
               <a:t>التسجيل</a:t>
             </a:r>
@@ -4517,13 +4481,12 @@
               <a:buNone/>
             </a:pPr>
             <a:r>
-              <a:rPr lang="ar-SA" altLang="en-US" sz="1200" dirty="0">
+              <a:rPr lang="ar-SA" sz="1200" dirty="0">
                 <a:solidFill>
                   <a:srgbClr val="B9C1C7"/>
                 </a:solidFill>
-                <a:latin typeface="Almarai Light" pitchFamily="34" charset="0"/>
-                <a:ea typeface="Almarai Light" pitchFamily="34" charset="-122"/>
-                <a:cs typeface="Almarai Light" pitchFamily="34" charset="-120"/>
+                <a:latin typeface="Almarai Light" pitchFamily="2" charset="-78"/>
+                <a:cs typeface="Almarai Light" pitchFamily="2" charset="-78"/>
               </a:rPr>
               <a:t>خدمات التسجيل بجميع أنواعها: أغانٍ دعائية، ألبومات، فويس أوفر، والعديد من الخدمات الأخرى.</a:t>
             </a:r>
@@ -4605,13 +4568,12 @@
               <a:buNone/>
             </a:pPr>
             <a:r>
-              <a:rPr lang="ar-SA" altLang="en-US" sz="1700" dirty="0">
+              <a:rPr lang="ar-SA" sz="1700" dirty="0">
                 <a:solidFill>
                   <a:srgbClr val="F1EFE8"/>
                 </a:solidFill>
-                <a:latin typeface="Almarai Bold" pitchFamily="34" charset="0"/>
-                <a:ea typeface="Almarai Bold" pitchFamily="34" charset="-122"/>
-                <a:cs typeface="Almarai Bold" pitchFamily="34" charset="-120"/>
+                <a:latin typeface="Almarai Bold" pitchFamily="2" charset="-78"/>
+                <a:cs typeface="Almarai Bold" pitchFamily="2" charset="-78"/>
               </a:rPr>
               <a:t>أغانٍ دعائية</a:t>
             </a:r>
@@ -4647,13 +4609,12 @@
               <a:buNone/>
             </a:pPr>
             <a:r>
-              <a:rPr lang="ar-SA" altLang="en-US" sz="1200" dirty="0">
+              <a:rPr lang="ar-SA" sz="1200" dirty="0">
                 <a:solidFill>
                   <a:srgbClr val="B9C1C7"/>
                 </a:solidFill>
-                <a:latin typeface="Almarai Light" pitchFamily="34" charset="0"/>
-                <a:ea typeface="Almarai Light" pitchFamily="34" charset="-122"/>
-                <a:cs typeface="Almarai Light" pitchFamily="34" charset="-120"/>
+                <a:latin typeface="Almarai Light" pitchFamily="2" charset="-78"/>
+                <a:cs typeface="Almarai Light" pitchFamily="2" charset="-78"/>
               </a:rPr>
               <a:t>صناعة المحتوى الغنائي الدعائي للشركات والجهات المعلنة لتحقيق أفضل النتائج التسويقية.</a:t>
             </a:r>
@@ -4735,13 +4696,12 @@
               <a:buNone/>
             </a:pPr>
             <a:r>
-              <a:rPr lang="ar-SA" altLang="en-US" sz="1700" dirty="0">
+              <a:rPr lang="ar-SA" sz="1700" dirty="0">
                 <a:solidFill>
                   <a:srgbClr val="F1EFE8"/>
                 </a:solidFill>
-                <a:latin typeface="Almarai Bold" pitchFamily="34" charset="0"/>
-                <a:ea typeface="Almarai Bold" pitchFamily="34" charset="-122"/>
-                <a:cs typeface="Almarai Bold" pitchFamily="34" charset="-120"/>
+                <a:latin typeface="Almarai Bold" pitchFamily="2" charset="-78"/>
+                <a:cs typeface="Almarai Bold" pitchFamily="2" charset="-78"/>
               </a:rPr>
               <a:t>أغاني الألبومات</a:t>
             </a:r>
@@ -4777,13 +4737,12 @@
               <a:buNone/>
             </a:pPr>
             <a:r>
-              <a:rPr lang="ar-SA" altLang="en-US" sz="1200" dirty="0">
+              <a:rPr lang="ar-SA" sz="1200" dirty="0">
                 <a:solidFill>
                   <a:srgbClr val="B9C1C7"/>
                 </a:solidFill>
-                <a:latin typeface="Almarai Light" pitchFamily="34" charset="0"/>
-                <a:ea typeface="Almarai Light" pitchFamily="34" charset="-122"/>
-                <a:cs typeface="Almarai Light" pitchFamily="34" charset="-120"/>
+                <a:latin typeface="Almarai Light" pitchFamily="2" charset="-78"/>
+                <a:cs typeface="Almarai Light" pitchFamily="2" charset="-78"/>
               </a:rPr>
               <a:t>منظومة متكاملة لإنتاج ألبومات مطربي الصف الأول في الخليج والعالم العربي، ودعم الفنانين الصاعدين.</a:t>
             </a:r>
@@ -4940,13 +4899,12 @@
               <a:buNone/>
             </a:pPr>
             <a:r>
-              <a:rPr lang="ar-SA" altLang="en-US" sz="4800" dirty="0">
+              <a:rPr lang="ar-SA" sz="4800" dirty="0">
                 <a:solidFill>
                   <a:srgbClr val="C2BFAF"/>
                 </a:solidFill>
-                <a:latin typeface="FF Taweel" pitchFamily="34" charset="0"/>
-                <a:ea typeface="FF Taweel" pitchFamily="34" charset="-122"/>
-                <a:cs typeface="FF Taweel" pitchFamily="34" charset="-120"/>
+                <a:latin typeface="FF Taweel" pitchFamily="2" charset="-78"/>
+                <a:cs typeface="FF Taweel" pitchFamily="2" charset="-78"/>
               </a:rPr>
               <a:t>الإنتاج الصوتي</a:t>
             </a:r>
@@ -4979,13 +4937,12 @@
               <a:buNone/>
             </a:pPr>
             <a:r>
-              <a:rPr lang="ar-SA" altLang="en-US" sz="1500" dirty="0">
+              <a:rPr lang="ar-SA" sz="1500" dirty="0">
                 <a:solidFill>
                   <a:srgbClr val="2AAFC4"/>
                 </a:solidFill>
-                <a:latin typeface="Almarai Bold" pitchFamily="34" charset="0"/>
-                <a:ea typeface="Almarai Bold" pitchFamily="34" charset="-122"/>
-                <a:cs typeface="Almarai Bold" pitchFamily="34" charset="-120"/>
+                <a:latin typeface="Almarai Bold" pitchFamily="2" charset="-78"/>
+                <a:cs typeface="Almarai Bold" pitchFamily="2" charset="-78"/>
               </a:rPr>
               <a:t>خدمات إنتاج صوتي احترافية بخبرة تتجاوز 25 عاماً</a:t>
             </a:r>
@@ -5047,17 +5004,16 @@
               <a:buNone/>
             </a:pPr>
             <a:r>
-              <a:rPr lang="en-US" sz="5400" dirty="0">
+              <a:rPr lang="ar-SA" sz="5400" dirty="0">
                 <a:solidFill>
                   <a:srgbClr val="FFFFFF"/>
                 </a:solidFill>
-                <a:latin typeface="Almarai ExtraBold" pitchFamily="34" charset="0"/>
-                <a:ea typeface="Almarai ExtraBold" pitchFamily="34" charset="-122"/>
-                <a:cs typeface="Almarai ExtraBold" pitchFamily="34" charset="-120"/>
+                <a:latin typeface="Almarai ExtraBold" pitchFamily="2" charset="-78"/>
+                <a:cs typeface="Almarai ExtraBold" pitchFamily="2" charset="-78"/>
               </a:rPr>
               <a:t>+25</a:t>
             </a:r>
-            <a:endParaRPr lang="en-US" sz="5400" dirty="0"/>
+            <a:endParaRPr lang="ar-SA" sz="5400" dirty="0"/>
           </a:p>
         </p:txBody>
       </p:sp>
@@ -5086,13 +5042,12 @@
               <a:buNone/>
             </a:pPr>
             <a:r>
-              <a:rPr lang="ar-SA" altLang="en-US" sz="1700" dirty="0">
+              <a:rPr lang="ar-SA" sz="1700" dirty="0">
                 <a:solidFill>
                   <a:srgbClr val="FFFFFF"/>
                 </a:solidFill>
-                <a:latin typeface="Almarai Bold" pitchFamily="34" charset="0"/>
-                <a:ea typeface="Almarai Bold" pitchFamily="34" charset="-122"/>
-                <a:cs typeface="Almarai Bold" pitchFamily="34" charset="-120"/>
+                <a:latin typeface="Almarai Bold" pitchFamily="2" charset="-78"/>
+                <a:cs typeface="Almarai Bold" pitchFamily="2" charset="-78"/>
               </a:rPr>
               <a:t>عاماً من الخبرة</a:t>
             </a:r>
@@ -5125,13 +5080,12 @@
               <a:buNone/>
             </a:pPr>
             <a:r>
-              <a:rPr lang="ar-SA" altLang="en-US" sz="1200" dirty="0">
+              <a:rPr lang="ar-SA" sz="1200" dirty="0">
                 <a:solidFill>
                   <a:srgbClr val="E4D6EE"/>
                 </a:solidFill>
-                <a:latin typeface="Almarai Light" pitchFamily="34" charset="0"/>
-                <a:ea typeface="Almarai Light" pitchFamily="34" charset="-122"/>
-                <a:cs typeface="Almarai Light" pitchFamily="34" charset="-120"/>
+                <a:latin typeface="Almarai Light" pitchFamily="2" charset="-78"/>
+                <a:cs typeface="Almarai Light" pitchFamily="2" charset="-78"/>
               </a:rPr>
               <a:t>في الإنتاج الصوتي المحترف</a:t>
             </a:r>
@@ -5250,13 +5204,12 @@
               <a:buNone/>
             </a:pPr>
             <a:r>
-              <a:rPr lang="ar-SA" altLang="en-US" sz="1300" dirty="0">
+              <a:rPr lang="ar-SA" sz="1300" dirty="0">
                 <a:solidFill>
                   <a:srgbClr val="F1EFE8"/>
                 </a:solidFill>
-                <a:latin typeface="Almarai Bold" pitchFamily="34" charset="0"/>
-                <a:ea typeface="Almarai Bold" pitchFamily="34" charset="-122"/>
-                <a:cs typeface="Almarai Bold" pitchFamily="34" charset="-120"/>
+                <a:latin typeface="Almarai Bold" pitchFamily="2" charset="-78"/>
+                <a:cs typeface="Almarai Bold" pitchFamily="2" charset="-78"/>
               </a:rPr>
               <a:t>إنتاج البودكاست الصوتي</a:t>
             </a:r>
@@ -5292,13 +5245,12 @@
               <a:buNone/>
             </a:pPr>
             <a:r>
-              <a:rPr lang="ar-SA" altLang="en-US" sz="1050" dirty="0">
+              <a:rPr lang="ar-SA" sz="1050" dirty="0">
                 <a:solidFill>
                   <a:srgbClr val="B9C1C7"/>
                 </a:solidFill>
-                <a:latin typeface="Almarai Light" pitchFamily="34" charset="0"/>
-                <a:ea typeface="Almarai Light" pitchFamily="34" charset="-122"/>
-                <a:cs typeface="Almarai Light" pitchFamily="34" charset="-120"/>
+                <a:latin typeface="Almarai Light" pitchFamily="2" charset="-78"/>
+                <a:cs typeface="Almarai Light" pitchFamily="2" charset="-78"/>
               </a:rPr>
               <a:t>إنتاج متكامل لحلقات البودكاست باحترافية حتى النسخة النهائية الجاهزة للنشر.</a:t>
             </a:r>
@@ -5417,13 +5369,12 @@
               <a:buNone/>
             </a:pPr>
             <a:r>
-              <a:rPr lang="ar-SA" altLang="en-US" sz="1300" dirty="0">
+              <a:rPr lang="ar-SA" sz="1300" dirty="0">
                 <a:solidFill>
                   <a:srgbClr val="F1EFE8"/>
                 </a:solidFill>
-                <a:latin typeface="Almarai Bold" pitchFamily="34" charset="0"/>
-                <a:ea typeface="Almarai Bold" pitchFamily="34" charset="-122"/>
-                <a:cs typeface="Almarai Bold" pitchFamily="34" charset="-120"/>
+                <a:latin typeface="Almarai Bold" pitchFamily="2" charset="-78"/>
+                <a:cs typeface="Almarai Bold" pitchFamily="2" charset="-78"/>
               </a:rPr>
               <a:t>هندسة وإخراج البودكاست</a:t>
             </a:r>
@@ -5459,13 +5410,12 @@
               <a:buNone/>
             </a:pPr>
             <a:r>
-              <a:rPr lang="ar-SA" altLang="en-US" sz="1050" dirty="0">
+              <a:rPr lang="ar-SA" sz="1050" dirty="0">
                 <a:solidFill>
                   <a:srgbClr val="B9C1C7"/>
                 </a:solidFill>
-                <a:latin typeface="Almarai Light" pitchFamily="34" charset="0"/>
-                <a:ea typeface="Almarai Light" pitchFamily="34" charset="-122"/>
-                <a:cs typeface="Almarai Light" pitchFamily="34" charset="-120"/>
+                <a:latin typeface="Almarai Light" pitchFamily="2" charset="-78"/>
+                <a:cs typeface="Almarai Light" pitchFamily="2" charset="-78"/>
               </a:rPr>
               <a:t>للبودكاست المسجَّل من طرفكم: هندسة صوتية وإخراج فني بجودة احترافية.</a:t>
             </a:r>
@@ -5584,13 +5534,12 @@
               <a:buNone/>
             </a:pPr>
             <a:r>
-              <a:rPr lang="ar-SA" altLang="en-US" sz="1300" dirty="0">
+              <a:rPr lang="ar-SA" sz="1300" dirty="0">
                 <a:solidFill>
                   <a:srgbClr val="F1EFE8"/>
                 </a:solidFill>
-                <a:latin typeface="Almarai Bold" pitchFamily="34" charset="0"/>
-                <a:ea typeface="Almarai Bold" pitchFamily="34" charset="-122"/>
-                <a:cs typeface="Almarai Bold" pitchFamily="34" charset="-120"/>
+                <a:latin typeface="Almarai Bold" pitchFamily="2" charset="-78"/>
+                <a:cs typeface="Almarai Bold" pitchFamily="2" charset="-78"/>
               </a:rPr>
               <a:t>رسائل الرد الآلي للشركات</a:t>
             </a:r>
@@ -5626,13 +5575,12 @@
               <a:buNone/>
             </a:pPr>
             <a:r>
-              <a:rPr lang="ar-SA" altLang="en-US" sz="1050" dirty="0">
+              <a:rPr lang="ar-SA" sz="1050" dirty="0">
                 <a:solidFill>
                   <a:srgbClr val="B9C1C7"/>
                 </a:solidFill>
-                <a:latin typeface="Almarai Light" pitchFamily="34" charset="0"/>
-                <a:ea typeface="Almarai Light" pitchFamily="34" charset="-122"/>
-                <a:cs typeface="Almarai Light" pitchFamily="34" charset="-120"/>
+                <a:latin typeface="Almarai Light" pitchFamily="2" charset="-78"/>
+                <a:cs typeface="Almarai Light" pitchFamily="2" charset="-78"/>
               </a:rPr>
               <a:t>رسائل ترحيب وقوائم رد آلي بأصوات احترافية تعكس هوية شركتكم.</a:t>
             </a:r>
@@ -5751,13 +5699,12 @@
               <a:buNone/>
             </a:pPr>
             <a:r>
-              <a:rPr lang="ar-SA" altLang="en-US" sz="1300" dirty="0">
+              <a:rPr lang="ar-SA" sz="1300" dirty="0">
                 <a:solidFill>
                   <a:srgbClr val="F1EFE8"/>
                 </a:solidFill>
-                <a:latin typeface="Almarai Bold" pitchFamily="34" charset="0"/>
-                <a:ea typeface="Almarai Bold" pitchFamily="34" charset="-122"/>
-                <a:cs typeface="Almarai Bold" pitchFamily="34" charset="-120"/>
+                <a:latin typeface="Almarai Bold" pitchFamily="2" charset="-78"/>
+                <a:cs typeface="Almarai Bold" pitchFamily="2" charset="-78"/>
               </a:rPr>
               <a:t>تحرير الصوت للمعلقين الصوتيين</a:t>
             </a:r>
@@ -5793,13 +5740,12 @@
               <a:buNone/>
             </a:pPr>
             <a:r>
-              <a:rPr lang="ar-SA" altLang="en-US" sz="1050" dirty="0">
+              <a:rPr lang="ar-SA" sz="1050" dirty="0">
                 <a:solidFill>
                   <a:srgbClr val="B9C1C7"/>
                 </a:solidFill>
-                <a:latin typeface="Almarai Light" pitchFamily="34" charset="0"/>
-                <a:ea typeface="Almarai Light" pitchFamily="34" charset="-122"/>
-                <a:cs typeface="Almarai Light" pitchFamily="34" charset="-120"/>
+                <a:latin typeface="Almarai Light" pitchFamily="2" charset="-78"/>
+                <a:cs typeface="Almarai Light" pitchFamily="2" charset="-78"/>
               </a:rPr>
               <a:t>تنقية وتحرير ومعالجة تسجيلات المعلقين لتسليمها بجودة عالية.</a:t>
             </a:r>
@@ -5918,13 +5864,12 @@
               <a:buNone/>
             </a:pPr>
             <a:r>
-              <a:rPr lang="ar-SA" altLang="en-US" sz="1300" dirty="0">
+              <a:rPr lang="ar-SA" sz="1300" dirty="0">
                 <a:solidFill>
                   <a:srgbClr val="F1EFE8"/>
                 </a:solidFill>
-                <a:latin typeface="Almarai Bold" pitchFamily="34" charset="0"/>
-                <a:ea typeface="Almarai Bold" pitchFamily="34" charset="-122"/>
-                <a:cs typeface="Almarai Bold" pitchFamily="34" charset="-120"/>
+                <a:latin typeface="Almarai Bold" pitchFamily="2" charset="-78"/>
+                <a:cs typeface="Almarai Bold" pitchFamily="2" charset="-78"/>
               </a:rPr>
               <a:t>توفير معلقين صوتيين</a:t>
             </a:r>
@@ -5960,13 +5905,12 @@
               <a:buNone/>
             </a:pPr>
             <a:r>
-              <a:rPr lang="ar-SA" altLang="en-US" sz="1050" dirty="0">
+              <a:rPr lang="ar-SA" sz="1050" dirty="0">
                 <a:solidFill>
                   <a:srgbClr val="B9C1C7"/>
                 </a:solidFill>
-                <a:latin typeface="Almarai Light" pitchFamily="34" charset="0"/>
-                <a:ea typeface="Almarai Light" pitchFamily="34" charset="-122"/>
-                <a:cs typeface="Almarai Light" pitchFamily="34" charset="-120"/>
+                <a:latin typeface="Almarai Light" pitchFamily="2" charset="-78"/>
+                <a:cs typeface="Almarai Light" pitchFamily="2" charset="-78"/>
               </a:rPr>
               <a:t>معلقون ومعلقات باللغتين العربية والإنجليزية لتناسب كل مشروع.</a:t>
             </a:r>
@@ -6085,13 +6029,12 @@
               <a:buNone/>
             </a:pPr>
             <a:r>
-              <a:rPr lang="ar-SA" altLang="en-US" sz="1300" dirty="0">
+              <a:rPr lang="ar-SA" sz="1300" dirty="0">
                 <a:solidFill>
                   <a:srgbClr val="F1EFE8"/>
                 </a:solidFill>
-                <a:latin typeface="Almarai Bold" pitchFamily="34" charset="0"/>
-                <a:ea typeface="Almarai Bold" pitchFamily="34" charset="-122"/>
-                <a:cs typeface="Almarai Bold" pitchFamily="34" charset="-120"/>
+                <a:latin typeface="Almarai Bold" pitchFamily="2" charset="-78"/>
+                <a:cs typeface="Almarai Bold" pitchFamily="2" charset="-78"/>
               </a:rPr>
               <a:t>التصميم الصوتي لمقاطع الفيديو</a:t>
             </a:r>
@@ -6127,13 +6070,12 @@
               <a:buNone/>
             </a:pPr>
             <a:r>
-              <a:rPr lang="ar-SA" altLang="en-US" sz="1050" dirty="0">
+              <a:rPr lang="ar-SA" sz="1050" dirty="0">
                 <a:solidFill>
                   <a:srgbClr val="B9C1C7"/>
                 </a:solidFill>
-                <a:latin typeface="Almarai Light" pitchFamily="34" charset="0"/>
-                <a:ea typeface="Almarai Light" pitchFamily="34" charset="-122"/>
-                <a:cs typeface="Almarai Light" pitchFamily="34" charset="-120"/>
+                <a:latin typeface="Almarai Light" pitchFamily="2" charset="-78"/>
+                <a:cs typeface="Almarai Light" pitchFamily="2" charset="-78"/>
               </a:rPr>
               <a:t>مؤثرات وموسيقى ومكساج يمنح مقاطع الفيديو حضوراً وتأثيراً أقوى.</a:t>
             </a:r>
@@ -6252,13 +6194,12 @@
               <a:buNone/>
             </a:pPr>
             <a:r>
-              <a:rPr lang="ar-SA" altLang="en-US" sz="1300" dirty="0">
+              <a:rPr lang="ar-SA" sz="1300" dirty="0">
                 <a:solidFill>
                   <a:srgbClr val="F1EFE8"/>
                 </a:solidFill>
-                <a:latin typeface="Almarai Bold" pitchFamily="34" charset="0"/>
-                <a:ea typeface="Almarai Bold" pitchFamily="34" charset="-122"/>
-                <a:cs typeface="Almarai Bold" pitchFamily="34" charset="-120"/>
+                <a:latin typeface="Almarai Bold" pitchFamily="2" charset="-78"/>
+                <a:cs typeface="Almarai Bold" pitchFamily="2" charset="-78"/>
               </a:rPr>
               <a:t>التعليق الصوتي للأفلام الوثائقية والموشن جرافيك</a:t>
             </a:r>
@@ -6294,13 +6235,12 @@
               <a:buNone/>
             </a:pPr>
             <a:r>
-              <a:rPr lang="ar-SA" altLang="en-US" sz="1050" dirty="0">
+              <a:rPr lang="ar-SA" sz="1050" dirty="0">
                 <a:solidFill>
                   <a:srgbClr val="B9C1C7"/>
                 </a:solidFill>
-                <a:latin typeface="Almarai Light" pitchFamily="34" charset="0"/>
-                <a:ea typeface="Almarai Light" pitchFamily="34" charset="-122"/>
-                <a:cs typeface="Almarai Light" pitchFamily="34" charset="-120"/>
+                <a:latin typeface="Almarai Light" pitchFamily="2" charset="-78"/>
+                <a:cs typeface="Almarai Light" pitchFamily="2" charset="-78"/>
               </a:rPr>
               <a:t>تعليق صوتي احترافي ينقل رسالتكم بوضوح وإحساس.</a:t>
             </a:r>
@@ -6457,13 +6397,12 @@
               <a:buNone/>
             </a:pPr>
             <a:r>
-              <a:rPr lang="ar-SA" altLang="en-US" sz="8000" dirty="0">
+              <a:rPr lang="ar-SA" sz="8000" dirty="0">
                 <a:solidFill>
                   <a:srgbClr val="C2BFAF"/>
                 </a:solidFill>
-                <a:latin typeface="FF Taweel" pitchFamily="34" charset="0"/>
-                <a:ea typeface="FF Taweel" pitchFamily="34" charset="-122"/>
-                <a:cs typeface="FF Taweel" pitchFamily="34" charset="-120"/>
+                <a:latin typeface="FF Taweel" pitchFamily="2" charset="-78"/>
+                <a:cs typeface="FF Taweel" pitchFamily="2" charset="-78"/>
               </a:rPr>
               <a:t>شكراً لكم</a:t>
             </a:r>
@@ -6496,13 +6435,12 @@
               <a:buNone/>
             </a:pPr>
             <a:r>
-              <a:rPr lang="ar-SA" altLang="en-US" sz="1800" dirty="0">
+              <a:rPr lang="ar-SA" sz="1800" dirty="0">
                 <a:solidFill>
                   <a:srgbClr val="2AAFC4"/>
                 </a:solidFill>
-                <a:latin typeface="Almarai Bold" pitchFamily="34" charset="0"/>
-                <a:ea typeface="Almarai Bold" pitchFamily="34" charset="-122"/>
-                <a:cs typeface="Almarai Bold" pitchFamily="34" charset="-120"/>
+                <a:latin typeface="Almarai Bold" pitchFamily="2" charset="-78"/>
+                <a:cs typeface="Almarai Bold" pitchFamily="2" charset="-78"/>
               </a:rPr>
               <a:t>سمع للإنتاج الإعلامي المرئي والمسموع</a:t>
             </a:r>

</xml_diff>